<commit_message>
Rebuild defence deck literature review: 6 diagram-driven slides (system development x3, network simulation, AI/ML, research gap), one process model per system, add Kelly & Knottenbelt (2015) citation
</commit_message>
<xml_diff>
--- a/report/DEFENCE_PRESENTATION_FINAL.pptx
+++ b/report/DEFENCE_PRESENTATION_FINAL.pptx
@@ -7,10 +7,14 @@
   <p:sldIdLst>
     <p:sldId id="256" r:id="rId2"/>
     <p:sldId id="257" r:id="rId3"/>
+    <p:sldId id="276" r:id="rId26"/>
     <p:sldId id="258" r:id="rId4"/>
     <p:sldId id="259" r:id="rId5"/>
     <p:sldId id="260" r:id="rId6"/>
     <p:sldId id="261" r:id="rId7"/>
+    <p:sldId id="277" r:id="rId27"/>
+    <p:sldId id="278" r:id="rId28"/>
+    <p:sldId id="279" r:id="rId29"/>
     <p:sldId id="262" r:id="rId8"/>
     <p:sldId id="263" r:id="rId9"/>
     <p:sldId id="264" r:id="rId10"/>
@@ -19,6 +23,7 @@
     <p:sldId id="267" r:id="rId13"/>
     <p:sldId id="268" r:id="rId14"/>
     <p:sldId id="269" r:id="rId15"/>
+    <p:sldId id="280" r:id="rId30"/>
     <p:sldId id="270" r:id="rId16"/>
     <p:sldId id="271" r:id="rId17"/>
     <p:sldId id="272" r:id="rId18"/>
@@ -3184,7 +3189,7 @@
                 <a:latin typeface="Calibri"/>
               </a:rPr>
               <a:t>DESIGN AND SIMULATION OF AN IoT-BASED
-SMART ENERGY MONITORING AND ALERT SYSTEM</a:t>
+SMART ENERGY MONITORING NETWORK WITH ALERT SYSTEM</a:t>
             </a:r>
           </a:p>
         </p:txBody>
@@ -3840,7 +3845,7 @@
                 </a:solidFill>
                 <a:latin typeface="Calibri"/>
               </a:rPr>
-              <a:t>10</a:t>
+              <a:t>14</a:t>
             </a:r>
           </a:p>
         </p:txBody>
@@ -4295,7 +4300,7 @@
                 </a:solidFill>
                 <a:latin typeface="Calibri"/>
               </a:rPr>
-              <a:t>11</a:t>
+              <a:t>15</a:t>
             </a:r>
           </a:p>
         </p:txBody>
@@ -4631,7 +4636,7 @@
                 </a:solidFill>
                 <a:latin typeface="Calibri"/>
               </a:rPr>
-              <a:t>12</a:t>
+              <a:t>16</a:t>
             </a:r>
           </a:p>
         </p:txBody>
@@ -5409,7 +5414,7 @@
                 </a:solidFill>
                 <a:latin typeface="Calibri"/>
               </a:rPr>
-              <a:t>13</a:t>
+              <a:t>17</a:t>
             </a:r>
           </a:p>
         </p:txBody>
@@ -6942,7 +6947,7 @@
                 </a:solidFill>
                 <a:latin typeface="Calibri"/>
               </a:rPr>
-              <a:t>14</a:t>
+              <a:t>18</a:t>
             </a:r>
           </a:p>
         </p:txBody>
@@ -7262,7 +7267,7 @@
                 </a:solidFill>
                 <a:latin typeface="Calibri"/>
               </a:rPr>
-              <a:t>15</a:t>
+              <a:t>20</a:t>
             </a:r>
           </a:p>
         </p:txBody>
@@ -7687,7 +7692,7 @@
                 </a:solidFill>
                 <a:latin typeface="Calibri"/>
               </a:rPr>
-              <a:t>16</a:t>
+              <a:t>21</a:t>
             </a:r>
           </a:p>
         </p:txBody>
@@ -8007,7 +8012,7 @@
                 </a:solidFill>
                 <a:latin typeface="Calibri"/>
               </a:rPr>
-              <a:t>17</a:t>
+              <a:t>22</a:t>
             </a:r>
           </a:p>
         </p:txBody>
@@ -8327,7 +8332,7 @@
                 </a:solidFill>
                 <a:latin typeface="Calibri"/>
               </a:rPr>
-              <a:t>18</a:t>
+              <a:t>23</a:t>
             </a:r>
           </a:p>
         </p:txBody>
@@ -8647,7 +8652,7 @@
                 </a:solidFill>
                 <a:latin typeface="Calibri"/>
               </a:rPr>
-              <a:t>19</a:t>
+              <a:t>24</a:t>
             </a:r>
           </a:p>
         </p:txBody>
@@ -8869,7 +8874,7 @@
                 </a:solidFill>
                 <a:latin typeface="Calibri"/>
               </a:rPr>
-              <a:t>5.   Literature Review</a:t>
+              <a:t>5.   Relevance and Beneficiaries</a:t>
             </a:r>
           </a:p>
           <a:p>
@@ -8888,32 +8893,9 @@
                 </a:solidFill>
                 <a:latin typeface="Calibri"/>
               </a:rPr>
-              <a:t>6.   Methodology</a:t>
-            </a:r>
-          </a:p>
-        </p:txBody>
-      </p:sp>
-      <p:sp>
-        <p:nvSpPr>
-          <p:cNvPr id="5" name="TextBox 4"/>
-          <p:cNvSpPr txBox="1"/>
-          <p:nvPr/>
-        </p:nvSpPr>
-        <p:spPr>
-          <a:xfrm>
-            <a:off x="6400800" y="1188720"/>
-            <a:ext cx="4572000" cy="4572000"/>
-          </a:xfrm>
-          <a:prstGeom prst="rect">
-            <a:avLst/>
-          </a:prstGeom>
-          <a:noFill/>
-        </p:spPr>
-        <p:txBody>
-          <a:bodyPr wrap="square">
-            <a:spAutoFit/>
-          </a:bodyPr>
-          <a:lstStyle/>
+              <a:t>6.   Project Activity Planning</a:t>
+            </a:r>
+          </a:p>
           <a:p>
             <a:pPr>
               <a:lnSpc>
@@ -8930,9 +8912,32 @@
                 </a:solidFill>
                 <a:latin typeface="Calibri"/>
               </a:rPr>
-              <a:t>7.   Proposed System Architecture</a:t>
-            </a:r>
-          </a:p>
+              <a:t>7.   Literature Review</a:t>
+            </a:r>
+          </a:p>
+        </p:txBody>
+      </p:sp>
+      <p:sp>
+        <p:nvSpPr>
+          <p:cNvPr id="5" name="TextBox 4"/>
+          <p:cNvSpPr txBox="1"/>
+          <p:nvPr/>
+        </p:nvSpPr>
+        <p:spPr>
+          <a:xfrm>
+            <a:off x="6400800" y="1188720"/>
+            <a:ext cx="4572000" cy="4572000"/>
+          </a:xfrm>
+          <a:prstGeom prst="rect">
+            <a:avLst/>
+          </a:prstGeom>
+          <a:noFill/>
+        </p:spPr>
+        <p:txBody>
+          <a:bodyPr wrap="square">
+            <a:spAutoFit/>
+          </a:bodyPr>
+          <a:lstStyle/>
           <a:p>
             <a:pPr>
               <a:lnSpc>
@@ -8949,7 +8954,7 @@
                 </a:solidFill>
                 <a:latin typeface="Calibri"/>
               </a:rPr>
-              <a:t>8.   Implementation</a:t>
+              <a:t>8.   Methodology</a:t>
             </a:r>
           </a:p>
           <a:p>
@@ -8968,7 +8973,7 @@
                 </a:solidFill>
                 <a:latin typeface="Calibri"/>
               </a:rPr>
-              <a:t>9.   Testing and Results</a:t>
+              <a:t>9.   Proposed System Architecture</a:t>
             </a:r>
           </a:p>
           <a:p>
@@ -8987,7 +8992,7 @@
                 </a:solidFill>
                 <a:latin typeface="Calibri"/>
               </a:rPr>
-              <a:t>10.  Findings and Challenges</a:t>
+              <a:t>10.  Implementation</a:t>
             </a:r>
           </a:p>
           <a:p>
@@ -9006,7 +9011,45 @@
                 </a:solidFill>
                 <a:latin typeface="Calibri"/>
               </a:rPr>
-              <a:t>11.  Conclusions and Recommendations</a:t>
+              <a:t>11.  Testing and Results</a:t>
+            </a:r>
+          </a:p>
+          <a:p>
+            <a:pPr>
+              <a:lnSpc>
+                <a:spcPct val="130000"/>
+              </a:lnSpc>
+              <a:spcAft>
+                <a:spcPts val="1200"/>
+              </a:spcAft>
+            </a:pPr>
+            <a:r>
+              <a:rPr sz="1800">
+                <a:solidFill>
+                  <a:srgbClr val="333333"/>
+                </a:solidFill>
+                <a:latin typeface="Calibri"/>
+              </a:rPr>
+              <a:t>12.  Findings and Challenges</a:t>
+            </a:r>
+          </a:p>
+          <a:p>
+            <a:pPr>
+              <a:lnSpc>
+                <a:spcPct val="130000"/>
+              </a:lnSpc>
+              <a:spcAft>
+                <a:spcPts val="1200"/>
+              </a:spcAft>
+            </a:pPr>
+            <a:r>
+              <a:rPr sz="1800">
+                <a:solidFill>
+                  <a:srgbClr val="333333"/>
+                </a:solidFill>
+                <a:latin typeface="Calibri"/>
+              </a:rPr>
+              <a:t>13.  Conclusions and Recommendations</a:t>
             </a:r>
           </a:p>
         </p:txBody>
@@ -9544,6 +9587,1384 @@
 </p:sld>
 </file>
 
+<file path=ppt/slides/slide21.xml><?xml version="1.0" encoding="utf-8"?>
+<p:sld xmlns:a="http://schemas.openxmlformats.org/drawingml/2006/main" xmlns:p="http://schemas.openxmlformats.org/presentationml/2006/main" xmlns:r="http://schemas.openxmlformats.org/officeDocument/2006/relationships">
+  <p:cSld>
+    <p:spTree>
+      <p:nvGrpSpPr>
+        <p:cNvPr id="1" name=""/>
+        <p:cNvGrpSpPr/>
+        <p:nvPr/>
+      </p:nvGrpSpPr>
+      <p:grpSpPr/>
+      <p:sp>
+        <p:nvSpPr>
+          <p:cNvPr id="2" name="Rectangle 1"/>
+          <p:cNvSpPr/>
+          <p:nvPr/>
+        </p:nvSpPr>
+        <p:spPr>
+          <a:xfrm>
+            <a:off x="0" y="0"/>
+            <a:ext cx="12191695" cy="822960"/>
+          </a:xfrm>
+          <a:prstGeom prst="rect">
+            <a:avLst/>
+          </a:prstGeom>
+          <a:solidFill>
+            <a:srgbClr val="003366"/>
+          </a:solidFill>
+          <a:ln>
+            <a:noFill/>
+          </a:ln>
+        </p:spPr>
+        <p:style>
+          <a:lnRef idx="1">
+            <a:schemeClr val="accent1"/>
+          </a:lnRef>
+          <a:fillRef idx="3">
+            <a:schemeClr val="accent1"/>
+          </a:fillRef>
+          <a:effectRef idx="2">
+            <a:schemeClr val="accent1"/>
+          </a:effectRef>
+          <a:fontRef idx="minor">
+            <a:schemeClr val="lt1"/>
+          </a:fontRef>
+        </p:style>
+        <p:txBody>
+          <a:bodyPr rtlCol="0" anchor="ctr"/>
+          <a:lstStyle/>
+          <a:p>
+            <a:pPr algn="ctr"/>
+            <a:endParaRPr/>
+          </a:p>
+        </p:txBody>
+      </p:sp>
+      <p:sp>
+        <p:nvSpPr>
+          <p:cNvPr id="3" name="TextBox 2"/>
+          <p:cNvSpPr txBox="1"/>
+          <p:nvPr/>
+        </p:nvSpPr>
+        <p:spPr>
+          <a:xfrm>
+            <a:off x="548640" y="109728"/>
+            <a:ext cx="10972800" cy="640080"/>
+          </a:xfrm>
+          <a:prstGeom prst="rect">
+            <a:avLst/>
+          </a:prstGeom>
+          <a:noFill/>
+        </p:spPr>
+        <p:txBody>
+          <a:bodyPr wrap="square">
+            <a:spAutoFit/>
+          </a:bodyPr>
+          <a:lstStyle/>
+          <a:p>
+            <a:pPr algn="l"/>
+            <a:r>
+              <a:rPr sz="2400" b="1">
+                <a:solidFill>
+                  <a:srgbClr val="FFFFFF"/>
+                </a:solidFill>
+                <a:latin typeface="Calibri"/>
+              </a:rPr>
+              <a:t>ABSTRACT</a:t>
+            </a:r>
+          </a:p>
+        </p:txBody>
+      </p:sp>
+      <p:sp>
+        <p:nvSpPr>
+          <p:cNvPr id="4" name="TextBox 3"/>
+          <p:cNvSpPr txBox="1"/>
+          <p:nvPr/>
+        </p:nvSpPr>
+        <p:spPr>
+          <a:xfrm>
+            <a:off x="731520" y="1097280"/>
+            <a:ext cx="10515600" cy="5029200"/>
+          </a:xfrm>
+          <a:prstGeom prst="rect">
+            <a:avLst/>
+          </a:prstGeom>
+          <a:noFill/>
+        </p:spPr>
+        <p:txBody>
+          <a:bodyPr wrap="square">
+            <a:spAutoFit/>
+          </a:bodyPr>
+          <a:lstStyle/>
+          <a:p>
+            <a:pPr>
+              <a:lnSpc>
+                <a:spcPct val="125000"/>
+              </a:lnSpc>
+              <a:spcAft>
+                <a:spcPts val="1200"/>
+              </a:spcAft>
+            </a:pPr>
+            <a:r>
+              <a:rPr sz="1600">
+                <a:solidFill>
+                  <a:srgbClr val="333333"/>
+                </a:solidFill>
+                <a:latin typeface="Calibri"/>
+              </a:rPr>
+              <a:t>Electrical energy is fundamental to modern life, yet most residential consumers have little visibility into their usage. This project designs and simulates an IoT-based smart energy monitoring network with an alert system for a residential building. The system comprises a Python-based device simulator that generates realistic electrical readings (voltage, current, power, energy, temperature, humidity) for twenty virtual smart meters; a Flask-based backend that receives, stores, and broadcasts the data through a REST API and WebSocket; and a real-time web dashboard built with HTML5, CSS3, JavaScript and Chart.js that presents live charts, device status cards, an alert panel, and a location-based device map. A threshold-based alert engine continuously detects abnormal conditions such as over/under-voltage, over-current, high power, high/low temperature, device offline, and usage anomalies, and notifies the user in real time. The system was developed using the Agile (Scrum) methodology and validated through unit, integration, validation, and security testing, with all 115 test cases passing. Recommendations include extending the simulation to physical hardware using ESP32 microcontrollers with PZEM-004T metering modules and adopting machine-learning-based anomaly detection.</a:t>
+            </a:r>
+          </a:p>
+        </p:txBody>
+      </p:sp>
+      <p:sp>
+        <p:nvSpPr>
+          <p:cNvPr id="5" name="Rectangle 4"/>
+          <p:cNvSpPr/>
+          <p:nvPr/>
+        </p:nvSpPr>
+        <p:spPr>
+          <a:xfrm>
+            <a:off x="457200" y="6537960"/>
+            <a:ext cx="11277295" cy="18288"/>
+          </a:xfrm>
+          <a:prstGeom prst="rect">
+            <a:avLst/>
+          </a:prstGeom>
+          <a:solidFill>
+            <a:srgbClr val="003366"/>
+          </a:solidFill>
+          <a:ln>
+            <a:noFill/>
+          </a:ln>
+        </p:spPr>
+        <p:style>
+          <a:lnRef idx="1">
+            <a:schemeClr val="accent1"/>
+          </a:lnRef>
+          <a:fillRef idx="3">
+            <a:schemeClr val="accent1"/>
+          </a:fillRef>
+          <a:effectRef idx="2">
+            <a:schemeClr val="accent1"/>
+          </a:effectRef>
+          <a:fontRef idx="minor">
+            <a:schemeClr val="lt1"/>
+          </a:fontRef>
+        </p:style>
+        <p:txBody>
+          <a:bodyPr rtlCol="0" anchor="ctr"/>
+          <a:lstStyle/>
+          <a:p>
+            <a:pPr algn="ctr"/>
+            <a:endParaRPr/>
+          </a:p>
+        </p:txBody>
+      </p:sp>
+      <p:sp>
+        <p:nvSpPr>
+          <p:cNvPr id="6" name="TextBox 5"/>
+          <p:cNvSpPr txBox="1"/>
+          <p:nvPr/>
+        </p:nvSpPr>
+        <p:spPr>
+          <a:xfrm>
+            <a:off x="11430000" y="6446520"/>
+            <a:ext cx="640080" cy="320040"/>
+          </a:xfrm>
+          <a:prstGeom prst="rect">
+            <a:avLst/>
+          </a:prstGeom>
+          <a:noFill/>
+        </p:spPr>
+        <p:txBody>
+          <a:bodyPr wrap="none">
+            <a:spAutoFit/>
+          </a:bodyPr>
+          <a:lstStyle/>
+          <a:p>
+            <a:pPr algn="r"/>
+            <a:r>
+              <a:rPr sz="1000">
+                <a:solidFill>
+                  <a:srgbClr val="333333"/>
+                </a:solidFill>
+                <a:latin typeface="Calibri"/>
+              </a:rPr>
+              <a:t>3</a:t>
+            </a:r>
+          </a:p>
+        </p:txBody>
+      </p:sp>
+    </p:spTree>
+  </p:cSld>
+  <p:clrMapOvr>
+    <a:masterClrMapping/>
+  </p:clrMapOvr>
+</p:sld>
+</file>
+
+<file path=ppt/slides/slide22.xml><?xml version="1.0" encoding="utf-8"?>
+<p:sld xmlns:a="http://schemas.openxmlformats.org/drawingml/2006/main" xmlns:p="http://schemas.openxmlformats.org/presentationml/2006/main" xmlns:r="http://schemas.openxmlformats.org/officeDocument/2006/relationships">
+  <p:cSld>
+    <p:spTree>
+      <p:nvGrpSpPr>
+        <p:cNvPr id="1" name=""/>
+        <p:cNvGrpSpPr/>
+        <p:nvPr/>
+      </p:nvGrpSpPr>
+      <p:grpSpPr/>
+      <p:sp>
+        <p:nvSpPr>
+          <p:cNvPr id="2" name="Rectangle 1"/>
+          <p:cNvSpPr/>
+          <p:nvPr/>
+        </p:nvSpPr>
+        <p:spPr>
+          <a:xfrm>
+            <a:off x="0" y="0"/>
+            <a:ext cx="12191695" cy="822960"/>
+          </a:xfrm>
+          <a:prstGeom prst="rect">
+            <a:avLst/>
+          </a:prstGeom>
+          <a:solidFill>
+            <a:srgbClr val="003366"/>
+          </a:solidFill>
+          <a:ln>
+            <a:noFill/>
+          </a:ln>
+        </p:spPr>
+        <p:style>
+          <a:lnRef idx="1">
+            <a:schemeClr val="accent1"/>
+          </a:lnRef>
+          <a:fillRef idx="3">
+            <a:schemeClr val="accent1"/>
+          </a:fillRef>
+          <a:effectRef idx="2">
+            <a:schemeClr val="accent1"/>
+          </a:effectRef>
+          <a:fontRef idx="minor">
+            <a:schemeClr val="lt1"/>
+          </a:fontRef>
+        </p:style>
+        <p:txBody>
+          <a:bodyPr rtlCol="0" anchor="ctr"/>
+          <a:lstStyle/>
+          <a:p>
+            <a:pPr algn="ctr"/>
+            <a:endParaRPr/>
+          </a:p>
+        </p:txBody>
+      </p:sp>
+      <p:sp>
+        <p:nvSpPr>
+          <p:cNvPr id="3" name="TextBox 2"/>
+          <p:cNvSpPr txBox="1"/>
+          <p:nvPr/>
+        </p:nvSpPr>
+        <p:spPr>
+          <a:xfrm>
+            <a:off x="548640" y="109728"/>
+            <a:ext cx="10972800" cy="640080"/>
+          </a:xfrm>
+          <a:prstGeom prst="rect">
+            <a:avLst/>
+          </a:prstGeom>
+          <a:noFill/>
+        </p:spPr>
+        <p:txBody>
+          <a:bodyPr wrap="square">
+            <a:spAutoFit/>
+          </a:bodyPr>
+          <a:lstStyle/>
+          <a:p>
+            <a:pPr algn="l"/>
+            <a:r>
+              <a:rPr sz="2400" b="1">
+                <a:solidFill>
+                  <a:srgbClr val="FFFFFF"/>
+                </a:solidFill>
+                <a:latin typeface="Calibri"/>
+              </a:rPr>
+              <a:t>ACADEMIC AND PRACTICAL RELEVANCE</a:t>
+            </a:r>
+          </a:p>
+        </p:txBody>
+      </p:sp>
+      <p:sp>
+        <p:nvSpPr>
+          <p:cNvPr id="4" name="TextBox 3"/>
+          <p:cNvSpPr txBox="1"/>
+          <p:nvPr/>
+        </p:nvSpPr>
+        <p:spPr>
+          <a:xfrm>
+            <a:off x="731520" y="1097280"/>
+            <a:ext cx="10515600" cy="5029200"/>
+          </a:xfrm>
+          <a:prstGeom prst="rect">
+            <a:avLst/>
+          </a:prstGeom>
+          <a:noFill/>
+        </p:spPr>
+        <p:txBody>
+          <a:bodyPr wrap="square">
+            <a:spAutoFit/>
+          </a:bodyPr>
+          <a:lstStyle/>
+          <a:p>
+            <a:pPr>
+              <a:lnSpc>
+                <a:spcPct val="125000"/>
+              </a:lnSpc>
+              <a:spcAft>
+                <a:spcPts val="1200"/>
+              </a:spcAft>
+            </a:pPr>
+            <a:r>
+              <a:rPr sz="1600">
+                <a:solidFill>
+                  <a:srgbClr val="333333"/>
+                </a:solidFill>
+                <a:latin typeface="Calibri"/>
+              </a:rPr>
+              <a:t>•  Academic Relevance — demonstrates the real-world application of IoT architecture (Perception, Network and Application layers) and provides a reusable platform for IoT and web-development teaching.</a:t>
+            </a:r>
+          </a:p>
+          <a:p>
+            <a:pPr/>
+            <a:r>
+              <a:rPr sz="1600">
+                <a:solidFill>
+                  <a:srgbClr val="333333"/>
+                </a:solidFill>
+                <a:latin typeface="Calibri"/>
+              </a:rPr>
+              <a:t>•  Practical Relevance — real-time visibility into consumption helps households reduce waste and lower bills, and offers a low-cost, zero-hardware template for larger deployments.</a:t>
+            </a:r>
+          </a:p>
+          <a:p>
+            <a:pPr/>
+            <a:r>
+              <a:rPr sz="1600">
+                <a:solidFill>
+                  <a:srgbClr val="333333"/>
+                </a:solidFill>
+                <a:latin typeface="Calibri"/>
+              </a:rPr>
+              <a:t>•  Beneficiaries — Households and residents gain awareness and cost savings.</a:t>
+            </a:r>
+          </a:p>
+          <a:p>
+            <a:pPr/>
+            <a:r>
+              <a:rPr sz="1600">
+                <a:solidFill>
+                  <a:srgbClr val="333333"/>
+                </a:solidFill>
+                <a:latin typeface="Calibri"/>
+              </a:rPr>
+              <a:t>•  Beneficiaries — Utility companies obtain representative demand and load data.</a:t>
+            </a:r>
+          </a:p>
+          <a:p>
+            <a:pPr/>
+            <a:r>
+              <a:rPr sz="1600">
+                <a:solidFill>
+                  <a:srgbClr val="333333"/>
+                </a:solidFill>
+                <a:latin typeface="Calibri"/>
+              </a:rPr>
+              <a:t>•  Beneficiaries — Students and researchers gain a hands-on IoT learning platform.</a:t>
+            </a:r>
+          </a:p>
+          <a:p>
+            <a:pPr/>
+            <a:r>
+              <a:rPr sz="1600">
+                <a:solidFill>
+                  <a:srgbClr val="333333"/>
+                </a:solidFill>
+                <a:latin typeface="Calibri"/>
+              </a:rPr>
+              <a:t>•  Beneficiaries — Policymakers receive evidence to support energy-efficiency policies.</a:t>
+            </a:r>
+          </a:p>
+        </p:txBody>
+      </p:sp>
+      <p:sp>
+        <p:nvSpPr>
+          <p:cNvPr id="5" name="Rectangle 4"/>
+          <p:cNvSpPr/>
+          <p:nvPr/>
+        </p:nvSpPr>
+        <p:spPr>
+          <a:xfrm>
+            <a:off x="457200" y="6537960"/>
+            <a:ext cx="11277295" cy="18288"/>
+          </a:xfrm>
+          <a:prstGeom prst="rect">
+            <a:avLst/>
+          </a:prstGeom>
+          <a:solidFill>
+            <a:srgbClr val="003366"/>
+          </a:solidFill>
+          <a:ln>
+            <a:noFill/>
+          </a:ln>
+        </p:spPr>
+        <p:style>
+          <a:lnRef idx="1">
+            <a:schemeClr val="accent1"/>
+          </a:lnRef>
+          <a:fillRef idx="3">
+            <a:schemeClr val="accent1"/>
+          </a:fillRef>
+          <a:effectRef idx="2">
+            <a:schemeClr val="accent1"/>
+          </a:effectRef>
+          <a:fontRef idx="minor">
+            <a:schemeClr val="lt1"/>
+          </a:fontRef>
+        </p:style>
+        <p:txBody>
+          <a:bodyPr rtlCol="0" anchor="ctr"/>
+          <a:lstStyle/>
+          <a:p>
+            <a:pPr algn="ctr"/>
+            <a:endParaRPr/>
+          </a:p>
+        </p:txBody>
+      </p:sp>
+      <p:sp>
+        <p:nvSpPr>
+          <p:cNvPr id="6" name="TextBox 5"/>
+          <p:cNvSpPr txBox="1"/>
+          <p:nvPr/>
+        </p:nvSpPr>
+        <p:spPr>
+          <a:xfrm>
+            <a:off x="11430000" y="6446520"/>
+            <a:ext cx="640080" cy="320040"/>
+          </a:xfrm>
+          <a:prstGeom prst="rect">
+            <a:avLst/>
+          </a:prstGeom>
+          <a:noFill/>
+        </p:spPr>
+        <p:txBody>
+          <a:bodyPr wrap="none">
+            <a:spAutoFit/>
+          </a:bodyPr>
+          <a:lstStyle/>
+          <a:p>
+            <a:pPr algn="r"/>
+            <a:r>
+              <a:rPr sz="1000">
+                <a:solidFill>
+                  <a:srgbClr val="333333"/>
+                </a:solidFill>
+                <a:latin typeface="Calibri"/>
+              </a:rPr>
+              <a:t>8</a:t>
+            </a:r>
+          </a:p>
+        </p:txBody>
+      </p:sp>
+    </p:spTree>
+  </p:cSld>
+  <p:clrMapOvr>
+    <a:masterClrMapping/>
+  </p:clrMapOvr>
+</p:sld>
+</file>
+
+<file path=ppt/slides/slide23.xml><?xml version="1.0" encoding="utf-8"?>
+<p:sld xmlns:a="http://schemas.openxmlformats.org/drawingml/2006/main" xmlns:p="http://schemas.openxmlformats.org/presentationml/2006/main" xmlns:r="http://schemas.openxmlformats.org/officeDocument/2006/relationships">
+  <p:cSld>
+    <p:spTree>
+      <p:nvGrpSpPr>
+        <p:cNvPr id="1" name=""/>
+        <p:cNvGrpSpPr/>
+        <p:nvPr/>
+      </p:nvGrpSpPr>
+      <p:grpSpPr/>
+      <p:sp>
+        <p:nvSpPr>
+          <p:cNvPr id="2" name="Rectangle 1"/>
+          <p:cNvSpPr/>
+          <p:nvPr/>
+        </p:nvSpPr>
+        <p:spPr>
+          <a:xfrm>
+            <a:off x="0" y="0"/>
+            <a:ext cx="12191695" cy="822960"/>
+          </a:xfrm>
+          <a:prstGeom prst="rect">
+            <a:avLst/>
+          </a:prstGeom>
+          <a:solidFill>
+            <a:srgbClr val="003366"/>
+          </a:solidFill>
+          <a:ln>
+            <a:noFill/>
+          </a:ln>
+        </p:spPr>
+        <p:style>
+          <a:lnRef idx="1">
+            <a:schemeClr val="accent1"/>
+          </a:lnRef>
+          <a:fillRef idx="3">
+            <a:schemeClr val="accent1"/>
+          </a:fillRef>
+          <a:effectRef idx="2">
+            <a:schemeClr val="accent1"/>
+          </a:effectRef>
+          <a:fontRef idx="minor">
+            <a:schemeClr val="lt1"/>
+          </a:fontRef>
+        </p:style>
+        <p:txBody>
+          <a:bodyPr rtlCol="0" anchor="ctr"/>
+          <a:lstStyle/>
+          <a:p>
+            <a:pPr algn="ctr"/>
+            <a:endParaRPr/>
+          </a:p>
+        </p:txBody>
+      </p:sp>
+      <p:sp>
+        <p:nvSpPr>
+          <p:cNvPr id="3" name="TextBox 2"/>
+          <p:cNvSpPr txBox="1"/>
+          <p:nvPr/>
+        </p:nvSpPr>
+        <p:spPr>
+          <a:xfrm>
+            <a:off x="548640" y="109728"/>
+            <a:ext cx="10972800" cy="640080"/>
+          </a:xfrm>
+          <a:prstGeom prst="rect">
+            <a:avLst/>
+          </a:prstGeom>
+          <a:noFill/>
+        </p:spPr>
+        <p:txBody>
+          <a:bodyPr wrap="square">
+            <a:spAutoFit/>
+          </a:bodyPr>
+          <a:lstStyle/>
+          <a:p>
+            <a:pPr algn="l"/>
+            <a:r>
+              <a:rPr sz="2400" b="1">
+                <a:solidFill>
+                  <a:srgbClr val="FFFFFF"/>
+                </a:solidFill>
+                <a:latin typeface="Calibri"/>
+              </a:rPr>
+              <a:t>PROJECT ACTIVITY PLANNING (12 WEEKS)</a:t>
+            </a:r>
+          </a:p>
+        </p:txBody>
+      </p:sp>
+      <p:sp>
+        <p:nvSpPr>
+          <p:cNvPr id="4" name="TextBox 3"/>
+          <p:cNvSpPr txBox="1"/>
+          <p:nvPr/>
+        </p:nvSpPr>
+        <p:spPr>
+          <a:xfrm>
+            <a:off x="731520" y="1097280"/>
+            <a:ext cx="10515600" cy="5029200"/>
+          </a:xfrm>
+          <a:prstGeom prst="rect">
+            <a:avLst/>
+          </a:prstGeom>
+          <a:noFill/>
+        </p:spPr>
+        <p:txBody>
+          <a:bodyPr wrap="square">
+            <a:spAutoFit/>
+          </a:bodyPr>
+          <a:lstStyle/>
+          <a:p>
+            <a:pPr>
+              <a:lnSpc>
+                <a:spcPct val="125000"/>
+              </a:lnSpc>
+              <a:spcAft>
+                <a:spcPts val="1200"/>
+              </a:spcAft>
+            </a:pPr>
+            <a:r>
+              <a:rPr sz="1600">
+                <a:solidFill>
+                  <a:srgbClr val="333333"/>
+                </a:solidFill>
+                <a:latin typeface="Calibri"/>
+              </a:rPr>
+              <a:t>•  Weeks 1–2 — Problem definition, literature review, and requirements gathering.</a:t>
+            </a:r>
+          </a:p>
+          <a:p>
+            <a:pPr/>
+            <a:r>
+              <a:rPr sz="1600">
+                <a:solidFill>
+                  <a:srgbClr val="333333"/>
+                </a:solidFill>
+                <a:latin typeface="Calibri"/>
+              </a:rPr>
+              <a:t>•  Weeks 3–4 — System architecture design and UML modelling.</a:t>
+            </a:r>
+          </a:p>
+          <a:p>
+            <a:pPr/>
+            <a:r>
+              <a:rPr sz="1600">
+                <a:solidFill>
+                  <a:srgbClr val="333333"/>
+                </a:solidFill>
+                <a:latin typeface="Calibri"/>
+              </a:rPr>
+              <a:t>•  Weeks 5–6 — Device simulator and backend REST API development.</a:t>
+            </a:r>
+          </a:p>
+          <a:p>
+            <a:pPr/>
+            <a:r>
+              <a:rPr sz="1600">
+                <a:solidFill>
+                  <a:srgbClr val="333333"/>
+                </a:solidFill>
+                <a:latin typeface="Calibri"/>
+              </a:rPr>
+              <a:t>•  Weeks 7–8 — Alert engine, WebSocket, and web dashboard development.</a:t>
+            </a:r>
+          </a:p>
+          <a:p>
+            <a:pPr/>
+            <a:r>
+              <a:rPr sz="1600">
+                <a:solidFill>
+                  <a:srgbClr val="333333"/>
+                </a:solidFill>
+                <a:latin typeface="Calibri"/>
+              </a:rPr>
+              <a:t>•  Weeks 9–10 — Unit, integration, validation, and security testing.</a:t>
+            </a:r>
+          </a:p>
+          <a:p>
+            <a:pPr/>
+            <a:r>
+              <a:rPr sz="1600">
+                <a:solidFill>
+                  <a:srgbClr val="333333"/>
+                </a:solidFill>
+                <a:latin typeface="Calibri"/>
+              </a:rPr>
+              <a:t>•  Weeks 11–12 — Documentation, screenshots, and defence preparation.</a:t>
+            </a:r>
+          </a:p>
+          <a:p>
+            <a:pPr/>
+            <a:r>
+              <a:rPr sz="1600">
+                <a:solidFill>
+                  <a:srgbClr val="333333"/>
+                </a:solidFill>
+                <a:latin typeface="Calibri"/>
+              </a:rPr>
+              <a:t>•  Tracked using the Agile (Scrum) methodology with a Gantt chart.</a:t>
+            </a:r>
+          </a:p>
+        </p:txBody>
+      </p:sp>
+      <p:sp>
+        <p:nvSpPr>
+          <p:cNvPr id="5" name="Rectangle 4"/>
+          <p:cNvSpPr/>
+          <p:nvPr/>
+        </p:nvSpPr>
+        <p:spPr>
+          <a:xfrm>
+            <a:off x="457200" y="6537960"/>
+            <a:ext cx="11277295" cy="18288"/>
+          </a:xfrm>
+          <a:prstGeom prst="rect">
+            <a:avLst/>
+          </a:prstGeom>
+          <a:solidFill>
+            <a:srgbClr val="003366"/>
+          </a:solidFill>
+          <a:ln>
+            <a:noFill/>
+          </a:ln>
+        </p:spPr>
+        <p:style>
+          <a:lnRef idx="1">
+            <a:schemeClr val="accent1"/>
+          </a:lnRef>
+          <a:fillRef idx="3">
+            <a:schemeClr val="accent1"/>
+          </a:fillRef>
+          <a:effectRef idx="2">
+            <a:schemeClr val="accent1"/>
+          </a:effectRef>
+          <a:fontRef idx="minor">
+            <a:schemeClr val="lt1"/>
+          </a:fontRef>
+        </p:style>
+        <p:txBody>
+          <a:bodyPr rtlCol="0" anchor="ctr"/>
+          <a:lstStyle/>
+          <a:p>
+            <a:pPr algn="ctr"/>
+            <a:endParaRPr/>
+          </a:p>
+        </p:txBody>
+      </p:sp>
+      <p:sp>
+        <p:nvSpPr>
+          <p:cNvPr id="6" name="TextBox 5"/>
+          <p:cNvSpPr txBox="1"/>
+          <p:nvPr/>
+        </p:nvSpPr>
+        <p:spPr>
+          <a:xfrm>
+            <a:off x="11430000" y="6446520"/>
+            <a:ext cx="640080" cy="320040"/>
+          </a:xfrm>
+          <a:prstGeom prst="rect">
+            <a:avLst/>
+          </a:prstGeom>
+          <a:noFill/>
+        </p:spPr>
+        <p:txBody>
+          <a:bodyPr wrap="none">
+            <a:spAutoFit/>
+          </a:bodyPr>
+          <a:lstStyle/>
+          <a:p>
+            <a:pPr algn="r"/>
+            <a:r>
+              <a:rPr sz="1000">
+                <a:solidFill>
+                  <a:srgbClr val="333333"/>
+                </a:solidFill>
+                <a:latin typeface="Calibri"/>
+              </a:rPr>
+              <a:t>9</a:t>
+            </a:r>
+          </a:p>
+        </p:txBody>
+      </p:sp>
+    </p:spTree>
+  </p:cSld>
+  <p:clrMapOvr>
+    <a:masterClrMapping/>
+  </p:clrMapOvr>
+</p:sld>
+</file>
+
+<file path=ppt/slides/slide24.xml><?xml version="1.0" encoding="utf-8"?>
+<p:sld xmlns:a="http://schemas.openxmlformats.org/drawingml/2006/main" xmlns:p="http://schemas.openxmlformats.org/presentationml/2006/main" xmlns:r="http://schemas.openxmlformats.org/officeDocument/2006/relationships">
+  <p:cSld>
+    <p:spTree>
+      <p:nvGrpSpPr>
+        <p:cNvPr id="1" name=""/>
+        <p:cNvGrpSpPr/>
+        <p:nvPr/>
+      </p:nvGrpSpPr>
+      <p:grpSpPr/>
+      <p:sp>
+        <p:nvSpPr>
+          <p:cNvPr id="2" name="Rectangle 1"/>
+          <p:cNvSpPr/>
+          <p:nvPr/>
+        </p:nvSpPr>
+        <p:spPr>
+          <a:xfrm>
+            <a:off x="0" y="0"/>
+            <a:ext cx="12191695" cy="822960"/>
+          </a:xfrm>
+          <a:prstGeom prst="rect">
+            <a:avLst/>
+          </a:prstGeom>
+          <a:solidFill>
+            <a:srgbClr val="003366"/>
+          </a:solidFill>
+          <a:ln>
+            <a:noFill/>
+          </a:ln>
+        </p:spPr>
+        <p:style>
+          <a:lnRef idx="1">
+            <a:schemeClr val="accent1"/>
+          </a:lnRef>
+          <a:fillRef idx="3">
+            <a:schemeClr val="accent1"/>
+          </a:fillRef>
+          <a:effectRef idx="2">
+            <a:schemeClr val="accent1"/>
+          </a:effectRef>
+          <a:fontRef idx="minor">
+            <a:schemeClr val="lt1"/>
+          </a:fontRef>
+        </p:style>
+        <p:txBody>
+          <a:bodyPr rtlCol="0" anchor="ctr"/>
+          <a:lstStyle/>
+          <a:p>
+            <a:pPr algn="ctr"/>
+            <a:endParaRPr/>
+          </a:p>
+        </p:txBody>
+      </p:sp>
+      <p:sp>
+        <p:nvSpPr>
+          <p:cNvPr id="3" name="TextBox 2"/>
+          <p:cNvSpPr txBox="1"/>
+          <p:nvPr/>
+        </p:nvSpPr>
+        <p:spPr>
+          <a:xfrm>
+            <a:off x="548640" y="109728"/>
+            <a:ext cx="10972800" cy="640080"/>
+          </a:xfrm>
+          <a:prstGeom prst="rect">
+            <a:avLst/>
+          </a:prstGeom>
+          <a:noFill/>
+        </p:spPr>
+        <p:txBody>
+          <a:bodyPr wrap="square">
+            <a:spAutoFit/>
+          </a:bodyPr>
+          <a:lstStyle/>
+          <a:p>
+            <a:pPr algn="l"/>
+            <a:r>
+              <a:rPr sz="2400" b="1">
+                <a:solidFill>
+                  <a:srgbClr val="FFFFFF"/>
+                </a:solidFill>
+                <a:latin typeface="Calibri"/>
+              </a:rPr>
+              <a:t>REVIEWED SYSTEMS</a:t>
+            </a:r>
+          </a:p>
+        </p:txBody>
+      </p:sp>
+      <p:sp>
+        <p:nvSpPr>
+          <p:cNvPr id="4" name="TextBox 3"/>
+          <p:cNvSpPr txBox="1"/>
+          <p:nvPr/>
+        </p:nvSpPr>
+        <p:spPr>
+          <a:xfrm>
+            <a:off x="731520" y="1097280"/>
+            <a:ext cx="10515600" cy="5029200"/>
+          </a:xfrm>
+          <a:prstGeom prst="rect">
+            <a:avLst/>
+          </a:prstGeom>
+          <a:noFill/>
+        </p:spPr>
+        <p:txBody>
+          <a:bodyPr wrap="square">
+            <a:spAutoFit/>
+          </a:bodyPr>
+          <a:lstStyle/>
+          <a:p>
+            <a:pPr>
+              <a:lnSpc>
+                <a:spcPct val="125000"/>
+              </a:lnSpc>
+              <a:spcAft>
+                <a:spcPts val="1200"/>
+              </a:spcAft>
+            </a:pPr>
+            <a:r>
+              <a:rPr sz="1600">
+                <a:solidFill>
+                  <a:srgbClr val="333333"/>
+                </a:solidFill>
+                <a:latin typeface="Calibri"/>
+              </a:rPr>
+              <a:t>•  AWS IoT Core — managed cloud IoT platform with MQTT broker, device shadow, and rules engine.</a:t>
+            </a:r>
+          </a:p>
+          <a:p>
+            <a:pPr lvl="1"/>
+            <a:r>
+              <a:rPr sz="1600">
+                <a:solidFill>
+                  <a:srgbClr val="333333"/>
+                </a:solidFill>
+                <a:latin typeface="Calibri"/>
+              </a:rPr>
+              <a:t>    –  Good: scalable, secure, fully managed. | Bad: paid subscription, cloud-only, complex.</a:t>
+            </a:r>
+          </a:p>
+          <a:p>
+            <a:pPr/>
+            <a:r>
+              <a:rPr sz="1600">
+                <a:solidFill>
+                  <a:srgbClr val="333333"/>
+                </a:solidFill>
+                <a:latin typeface="Calibri"/>
+              </a:rPr>
+              <a:t>•  openHAB — open-source home-automation platform with bindings and a rule engine.</a:t>
+            </a:r>
+          </a:p>
+          <a:p>
+            <a:pPr lvl="1"/>
+            <a:r>
+              <a:rPr sz="1600">
+                <a:solidFill>
+                  <a:srgbClr val="333333"/>
+                </a:solidFill>
+                <a:latin typeface="Calibri"/>
+              </a:rPr>
+              <a:t>    –  Good: free, extensible, local-first. | Bad: Java dependency, steep learning curve, dated UI.</a:t>
+            </a:r>
+          </a:p>
+          <a:p>
+            <a:pPr/>
+            <a:r>
+              <a:rPr sz="1600">
+                <a:solidFill>
+                  <a:srgbClr val="333333"/>
+                </a:solidFill>
+                <a:latin typeface="Calibri"/>
+              </a:rPr>
+              <a:t>•  Blynk IoT Platform — low-code mobile-app builder with cloud backend.</a:t>
+            </a:r>
+          </a:p>
+          <a:p>
+            <a:pPr lvl="1"/>
+            <a:r>
+              <a:rPr sz="1600">
+                <a:solidFill>
+                  <a:srgbClr val="333333"/>
+                </a:solidFill>
+                <a:latin typeface="Calibri"/>
+              </a:rPr>
+              <a:t>    –  Good: rapid prototyping, easy to use. | Bad: subscription cost, limited analytics.</a:t>
+            </a:r>
+          </a:p>
+          <a:p>
+            <a:pPr/>
+            <a:r>
+              <a:rPr sz="1600">
+                <a:solidFill>
+                  <a:srgbClr val="333333"/>
+                </a:solidFill>
+                <a:latin typeface="Calibri"/>
+              </a:rPr>
+              <a:t>•  ESP32 + PZEM-004T — hardware reference: microcontroller and energy metering module.</a:t>
+            </a:r>
+          </a:p>
+          <a:p>
+            <a:pPr lvl="1"/>
+            <a:r>
+              <a:rPr sz="1600">
+                <a:solidFill>
+                  <a:srgbClr val="333333"/>
+                </a:solidFill>
+                <a:latin typeface="Calibri"/>
+              </a:rPr>
+              <a:t>    –  Good: real sensing, low cost. | Bad: physical wiring, calibration, power-supply constraints.</a:t>
+            </a:r>
+          </a:p>
+          <a:p>
+            <a:pPr/>
+            <a:r>
+              <a:rPr sz="1600">
+                <a:solidFill>
+                  <a:srgbClr val="333333"/>
+                </a:solidFill>
+                <a:latin typeface="Calibri"/>
+              </a:rPr>
+              <a:t>Summary — unlike these systems, ours is fully simulation-based, lightweight, and requires no hardware or cloud subscription.</a:t>
+            </a:r>
+          </a:p>
+        </p:txBody>
+      </p:sp>
+      <p:sp>
+        <p:nvSpPr>
+          <p:cNvPr id="5" name="Rectangle 4"/>
+          <p:cNvSpPr/>
+          <p:nvPr/>
+        </p:nvSpPr>
+        <p:spPr>
+          <a:xfrm>
+            <a:off x="457200" y="6537960"/>
+            <a:ext cx="11277295" cy="18288"/>
+          </a:xfrm>
+          <a:prstGeom prst="rect">
+            <a:avLst/>
+          </a:prstGeom>
+          <a:solidFill>
+            <a:srgbClr val="003366"/>
+          </a:solidFill>
+          <a:ln>
+            <a:noFill/>
+          </a:ln>
+        </p:spPr>
+        <p:style>
+          <a:lnRef idx="1">
+            <a:schemeClr val="accent1"/>
+          </a:lnRef>
+          <a:fillRef idx="3">
+            <a:schemeClr val="accent1"/>
+          </a:fillRef>
+          <a:effectRef idx="2">
+            <a:schemeClr val="accent1"/>
+          </a:effectRef>
+          <a:fontRef idx="minor">
+            <a:schemeClr val="lt1"/>
+          </a:fontRef>
+        </p:style>
+        <p:txBody>
+          <a:bodyPr rtlCol="0" anchor="ctr"/>
+          <a:lstStyle/>
+          <a:p>
+            <a:pPr algn="ctr"/>
+            <a:endParaRPr/>
+          </a:p>
+        </p:txBody>
+      </p:sp>
+      <p:sp>
+        <p:nvSpPr>
+          <p:cNvPr id="6" name="TextBox 5"/>
+          <p:cNvSpPr txBox="1"/>
+          <p:nvPr/>
+        </p:nvSpPr>
+        <p:spPr>
+          <a:xfrm>
+            <a:off x="11430000" y="6446520"/>
+            <a:ext cx="640080" cy="320040"/>
+          </a:xfrm>
+          <a:prstGeom prst="rect">
+            <a:avLst/>
+          </a:prstGeom>
+          <a:noFill/>
+        </p:spPr>
+        <p:txBody>
+          <a:bodyPr wrap="none">
+            <a:spAutoFit/>
+          </a:bodyPr>
+          <a:lstStyle/>
+          <a:p>
+            <a:pPr algn="r"/>
+            <a:r>
+              <a:rPr sz="1000">
+                <a:solidFill>
+                  <a:srgbClr val="333333"/>
+                </a:solidFill>
+                <a:latin typeface="Calibri"/>
+              </a:rPr>
+              <a:t>10</a:t>
+            </a:r>
+          </a:p>
+        </p:txBody>
+      </p:sp>
+    </p:spTree>
+  </p:cSld>
+  <p:clrMapOvr>
+    <a:masterClrMapping/>
+  </p:clrMapOvr>
+</p:sld>
+</file>
+
+<file path=ppt/slides/slide25.xml><?xml version="1.0" encoding="utf-8"?>
+<p:sld xmlns:a="http://schemas.openxmlformats.org/drawingml/2006/main" xmlns:p="http://schemas.openxmlformats.org/presentationml/2006/main" xmlns:r="http://schemas.openxmlformats.org/officeDocument/2006/relationships">
+  <p:cSld>
+    <p:spTree>
+      <p:nvGrpSpPr>
+        <p:cNvPr id="1" name=""/>
+        <p:cNvGrpSpPr/>
+        <p:nvPr/>
+      </p:nvGrpSpPr>
+      <p:grpSpPr/>
+      <p:sp>
+        <p:nvSpPr>
+          <p:cNvPr id="2" name="Rectangle 1"/>
+          <p:cNvSpPr/>
+          <p:nvPr/>
+        </p:nvSpPr>
+        <p:spPr>
+          <a:xfrm>
+            <a:off x="0" y="0"/>
+            <a:ext cx="12191695" cy="822960"/>
+          </a:xfrm>
+          <a:prstGeom prst="rect">
+            <a:avLst/>
+          </a:prstGeom>
+          <a:solidFill>
+            <a:srgbClr val="003366"/>
+          </a:solidFill>
+          <a:ln>
+            <a:noFill/>
+          </a:ln>
+        </p:spPr>
+        <p:style>
+          <a:lnRef idx="1">
+            <a:schemeClr val="accent1"/>
+          </a:lnRef>
+          <a:fillRef idx="3">
+            <a:schemeClr val="accent1"/>
+          </a:fillRef>
+          <a:effectRef idx="2">
+            <a:schemeClr val="accent1"/>
+          </a:effectRef>
+          <a:fontRef idx="minor">
+            <a:schemeClr val="lt1"/>
+          </a:fontRef>
+        </p:style>
+        <p:txBody>
+          <a:bodyPr rtlCol="0" anchor="ctr"/>
+          <a:lstStyle/>
+          <a:p>
+            <a:pPr algn="ctr"/>
+            <a:endParaRPr/>
+          </a:p>
+        </p:txBody>
+      </p:sp>
+      <p:sp>
+        <p:nvSpPr>
+          <p:cNvPr id="3" name="TextBox 2"/>
+          <p:cNvSpPr txBox="1"/>
+          <p:nvPr/>
+        </p:nvSpPr>
+        <p:spPr>
+          <a:xfrm>
+            <a:off x="548640" y="109728"/>
+            <a:ext cx="10972800" cy="640080"/>
+          </a:xfrm>
+          <a:prstGeom prst="rect">
+            <a:avLst/>
+          </a:prstGeom>
+          <a:noFill/>
+        </p:spPr>
+        <p:txBody>
+          <a:bodyPr wrap="square">
+            <a:spAutoFit/>
+          </a:bodyPr>
+          <a:lstStyle/>
+          <a:p>
+            <a:pPr algn="l"/>
+            <a:r>
+              <a:rPr sz="2400" b="1">
+                <a:solidFill>
+                  <a:srgbClr val="FFFFFF"/>
+                </a:solidFill>
+                <a:latin typeface="Calibri"/>
+              </a:rPr>
+              <a:t>TESTING AND RESULTS</a:t>
+            </a:r>
+          </a:p>
+        </p:txBody>
+      </p:sp>
+      <p:sp>
+        <p:nvSpPr>
+          <p:cNvPr id="4" name="TextBox 3"/>
+          <p:cNvSpPr txBox="1"/>
+          <p:nvPr/>
+        </p:nvSpPr>
+        <p:spPr>
+          <a:xfrm>
+            <a:off x="731520" y="1097280"/>
+            <a:ext cx="10515600" cy="5029200"/>
+          </a:xfrm>
+          <a:prstGeom prst="rect">
+            <a:avLst/>
+          </a:prstGeom>
+          <a:noFill/>
+        </p:spPr>
+        <p:txBody>
+          <a:bodyPr wrap="square">
+            <a:spAutoFit/>
+          </a:bodyPr>
+          <a:lstStyle/>
+          <a:p>
+            <a:pPr>
+              <a:lnSpc>
+                <a:spcPct val="125000"/>
+              </a:lnSpc>
+              <a:spcAft>
+                <a:spcPts val="1200"/>
+              </a:spcAft>
+            </a:pPr>
+            <a:r>
+              <a:rPr sz="1600">
+                <a:solidFill>
+                  <a:srgbClr val="333333"/>
+                </a:solidFill>
+                <a:latin typeface="Calibri"/>
+              </a:rPr>
+              <a:t>•  Testing plan — unit, integration, validation, and security testing; all 115 test cases passed.</a:t>
+            </a:r>
+          </a:p>
+          <a:p>
+            <a:pPr/>
+            <a:r>
+              <a:rPr sz="1600">
+                <a:solidFill>
+                  <a:srgbClr val="333333"/>
+                </a:solidFill>
+                <a:latin typeface="Calibri"/>
+              </a:rPr>
+              <a:t>•  Verification — database schema, REST API endpoints, authentication (bcrypt), and input validation.</a:t>
+            </a:r>
+          </a:p>
+          <a:p>
+            <a:pPr/>
+            <a:r>
+              <a:rPr sz="1600">
+                <a:solidFill>
+                  <a:srgbClr val="333333"/>
+                </a:solidFill>
+                <a:latin typeface="Calibri"/>
+              </a:rPr>
+              <a:t>•  Validation — all six specific objectives verified against live simulated data streaming.</a:t>
+            </a:r>
+          </a:p>
+          <a:p>
+            <a:pPr/>
+            <a:r>
+              <a:rPr sz="1600">
+                <a:solidFill>
+                  <a:srgbClr val="333333"/>
+                </a:solidFill>
+                <a:latin typeface="Calibri"/>
+              </a:rPr>
+              <a:t>•  Security — password hashing, session management, and login enforcement on all protected API routes.</a:t>
+            </a:r>
+          </a:p>
+          <a:p>
+            <a:pPr/>
+            <a:r>
+              <a:rPr sz="1600">
+                <a:solidFill>
+                  <a:srgbClr val="333333"/>
+                </a:solidFill>
+                <a:latin typeface="Calibri"/>
+              </a:rPr>
+              <a:t>•  Real-time delivery — live charts and WebSocket alerts update in real time as readings stream in.</a:t>
+            </a:r>
+          </a:p>
+          <a:p>
+            <a:pPr/>
+            <a:r>
+              <a:rPr sz="1600">
+                <a:solidFill>
+                  <a:srgbClr val="333333"/>
+                </a:solidFill>
+                <a:latin typeface="Calibri"/>
+              </a:rPr>
+              <a:t>•  Responses to feedback — persistent storage adopted (PostgreSQL on Render); duplicate alerts suppressed.</a:t>
+            </a:r>
+          </a:p>
+        </p:txBody>
+      </p:sp>
+      <p:sp>
+        <p:nvSpPr>
+          <p:cNvPr id="5" name="Rectangle 4"/>
+          <p:cNvSpPr/>
+          <p:nvPr/>
+        </p:nvSpPr>
+        <p:spPr>
+          <a:xfrm>
+            <a:off x="457200" y="6537960"/>
+            <a:ext cx="11277295" cy="18288"/>
+          </a:xfrm>
+          <a:prstGeom prst="rect">
+            <a:avLst/>
+          </a:prstGeom>
+          <a:solidFill>
+            <a:srgbClr val="003366"/>
+          </a:solidFill>
+          <a:ln>
+            <a:noFill/>
+          </a:ln>
+        </p:spPr>
+        <p:style>
+          <a:lnRef idx="1">
+            <a:schemeClr val="accent1"/>
+          </a:lnRef>
+          <a:fillRef idx="3">
+            <a:schemeClr val="accent1"/>
+          </a:fillRef>
+          <a:effectRef idx="2">
+            <a:schemeClr val="accent1"/>
+          </a:effectRef>
+          <a:fontRef idx="minor">
+            <a:schemeClr val="lt1"/>
+          </a:fontRef>
+        </p:style>
+        <p:txBody>
+          <a:bodyPr rtlCol="0" anchor="ctr"/>
+          <a:lstStyle/>
+          <a:p>
+            <a:pPr algn="ctr"/>
+            <a:endParaRPr/>
+          </a:p>
+        </p:txBody>
+      </p:sp>
+      <p:sp>
+        <p:nvSpPr>
+          <p:cNvPr id="6" name="TextBox 5"/>
+          <p:cNvSpPr txBox="1"/>
+          <p:nvPr/>
+        </p:nvSpPr>
+        <p:spPr>
+          <a:xfrm>
+            <a:off x="11430000" y="6446520"/>
+            <a:ext cx="640080" cy="320040"/>
+          </a:xfrm>
+          <a:prstGeom prst="rect">
+            <a:avLst/>
+          </a:prstGeom>
+          <a:noFill/>
+        </p:spPr>
+        <p:txBody>
+          <a:bodyPr wrap="none">
+            <a:spAutoFit/>
+          </a:bodyPr>
+          <a:lstStyle/>
+          <a:p>
+            <a:pPr algn="r"/>
+            <a:r>
+              <a:rPr sz="1000">
+                <a:solidFill>
+                  <a:srgbClr val="333333"/>
+                </a:solidFill>
+                <a:latin typeface="Calibri"/>
+              </a:rPr>
+              <a:t>19</a:t>
+            </a:r>
+          </a:p>
+        </p:txBody>
+      </p:sp>
+    </p:spTree>
+  </p:cSld>
+  <p:clrMapOvr>
+    <a:masterClrMapping/>
+  </p:clrMapOvr>
+</p:sld>
+</file>
+
 <file path=ppt/slides/slide3.xml><?xml version="1.0" encoding="utf-8"?>
 <p:sld xmlns:a="http://schemas.openxmlformats.org/drawingml/2006/main" xmlns:r="http://schemas.openxmlformats.org/officeDocument/2006/relationships" xmlns:p="http://schemas.openxmlformats.org/presentationml/2006/main">
   <p:cSld>
@@ -9851,7 +11272,7 @@
                 </a:solidFill>
                 <a:latin typeface="Calibri"/>
               </a:rPr>
-              <a:t>3</a:t>
+              <a:t>4</a:t>
             </a:r>
           </a:p>
         </p:txBody>
@@ -10222,7 +11643,7 @@
                 </a:solidFill>
                 <a:latin typeface="Calibri"/>
               </a:rPr>
-              <a:t>4</a:t>
+              <a:t>5</a:t>
             </a:r>
           </a:p>
         </p:txBody>
@@ -10644,7 +12065,7 @@
                 </a:solidFill>
                 <a:latin typeface="Calibri"/>
               </a:rPr>
-              <a:t>5</a:t>
+              <a:t>6</a:t>
             </a:r>
           </a:p>
         </p:txBody>
@@ -11131,7 +12552,7 @@
                 </a:solidFill>
                 <a:latin typeface="Calibri"/>
               </a:rPr>
-              <a:t>6</a:t>
+              <a:t>7</a:t>
             </a:r>
           </a:p>
         </p:txBody>
@@ -12011,7 +13432,7 @@
                 </a:solidFill>
                 <a:latin typeface="Calibri"/>
               </a:rPr>
-              <a:t>7</a:t>
+              <a:t>11</a:t>
             </a:r>
           </a:p>
         </p:txBody>
@@ -12910,7 +14331,7 @@
                 </a:solidFill>
                 <a:latin typeface="Calibri"/>
               </a:rPr>
-              <a:t>8</a:t>
+              <a:t>12</a:t>
             </a:r>
           </a:p>
         </p:txBody>
@@ -13711,7 +15132,7 @@
                 </a:solidFill>
                 <a:latin typeface="Calibri"/>
               </a:rPr>
-              <a:t>9</a:t>
+              <a:t>13</a:t>
             </a:r>
           </a:p>
         </p:txBody>

</xml_diff>